<commit_message>
Troca exemplo do integrante 4 para erro na separação do pedido (logística)
Co-Authored-By: Claude Opus 5.5 <noreply@anthropic.com>
Claude-Session: https://claude.ai/code/session_01E4wB5DMDRLvxuMcN1wRscX
</commit_message>
<xml_diff>
--- a/apresentacao-andon.pptx
+++ b/apresentacao-andon.pptx
@@ -119,12 +119,12 @@
   <p:extLst>
     <p:ext uri="{521415D9-36F7-43E2-AB2F-B90AF26B5E84}">
       <p14:sectionLst xmlns:p14="http://schemas.microsoft.com/office/powerpoint/2010/main">
-        <p14:section name="Abertura" id="{571cf1b0-d0a8-73f8-56fe-83efcc6f8a39}">
+        <p14:section name="Abertura" id="{fe74d636-3e3b-9278-ae02-ea1b29dc2ed2}">
           <p14:sldIdLst>
             <p14:sldId id="256"/>
           </p14:sldIdLst>
         </p14:section>
-        <p14:section name="Conceito" id="{040640d0-38d0-d8e4-6eeb-1e872aefc24a}">
+        <p14:section name="Conceito" id="{118ef3a6-1d92-12e2-898c-c623706ef256}">
           <p14:sldIdLst>
             <p14:sldId id="257"/>
             <p14:sldId id="258"/>
@@ -134,20 +134,20 @@
             <p14:sldId id="262"/>
           </p14:sldIdLst>
         </p14:section>
-        <p14:section name="Aplicação" id="{54a1e0d4-d342-b07b-6408-0bc085616cc7}">
+        <p14:section name="Aplicação" id="{2f10b7a6-d1d6-094b-2d48-66b7e9f6c54b}">
           <p14:sldIdLst>
             <p14:sldId id="263"/>
             <p14:sldId id="264"/>
           </p14:sldIdLst>
         </p14:section>
-        <p14:section name="Prática" id="{90e91ec4-8856-d2e2-c433-f848f8283640}">
+        <p14:section name="Prática" id="{5beb476f-26ba-0b49-e219-7de9ab5c7b34}">
           <p14:sldIdLst>
             <p14:sldId id="265"/>
             <p14:sldId id="266"/>
             <p14:sldId id="267"/>
           </p14:sldIdLst>
         </p14:section>
-        <p14:section name="Fechamento" id="{80878bf0-2a38-f7a7-c0ea-d9443705773c}">
+        <p14:section name="Fechamento" id="{0a8b9c98-737a-b712-702f-a4809ccb122d}">
           <p14:sldIdLst>
             <p14:sldId id="268"/>
           </p14:sldIdLst>
@@ -1627,8 +1627,8 @@
           <a:p>
             <a:r>
               <a:rPr lang="en-US" dirty="0"/>
-              <a:t>Meu exemplo é em serviços. Pense em uma central de atendimento. O atendente recebe um cliente com um problema urgente. Ele aciona um alerta no sistema. O supervisor vê o alerta na hora e vai ajudar. O problema é resolvido sem o cliente esperar. Depois, o chamado fica registrado. A equipe vê quais problemas se repetem. É o mesmo princípio do Andon na fábrica: sinalizar, chamar ajuda e registrar.
-Alternativa (indústria): O operador percebe uma peça fora do padrão. Ele aciona o Andon. A qualidade vem verificar antes de o lote continuar. Isso evita que o defeito avance para a próxima etapa.</a:t>
+              <a:t>Meu exemplo é na logística, em um centro de distribuição. O colaborador está separando um pedido e percebe um item trocado ou faltando. Em vez de seguir, ele aciona o Andon. A liderança vem até o posto e confere o pedido antes da expedição. O erro é corrigido ali, e não na casa do cliente. Isso evita devolução, reenvio e custo extra. Como o chamado fica registrado, a equipe descobre onde os erros se repetem, por exemplo produtos parecidos guardados lado a lado. É o mesmo princípio do Andon: sinalizar, chamar ajuda e corrigir antes de o problema avançar.
+Se perguntarem: o Andon não corrige o pedido sozinho. Ele faz o erro aparecer e chama a liderança antes da expedição.</a:t>
             </a:r>
             <a:endParaRPr lang="en-US" dirty="0"/>
           </a:p>
@@ -11170,7 +11170,7 @@
                   <a:schemeClr val="tx2"/>
                 </a:solidFill>
               </a:rPr>
-              <a:t>Serviço: atendimento</a:t>
+              <a:t>Logística: separação</a:t>
             </a:r>
             <a:endParaRPr lang="en-US" sz="1600" dirty="0"/>
           </a:p>
@@ -11206,7 +11206,7 @@
                   <a:schemeClr val="tx1"/>
                 </a:solidFill>
               </a:rPr>
-              <a:t>O atendente aciona um alerta no sistema e o supervisor vê na hora e vai ajudar.</a:t>
+              <a:t>O colaborador aciona o Andon ao notar item trocado ou faltando, e a liderança confere o pedido antes da expedição.</a:t>
             </a:r>
             <a:endParaRPr lang="en-US" sz="1300" dirty="0"/>
           </a:p>
@@ -11314,7 +11314,7 @@
                   <a:schemeClr val="tx2"/>
                 </a:solidFill>
               </a:rPr>
-              <a:t>Exemplo: central de atendimento</a:t>
+              <a:t>Exemplo: erro na separação do pedido</a:t>
             </a:r>
             <a:endParaRPr lang="en-US" sz="3200" dirty="0"/>
           </a:p>
@@ -11435,7 +11435,7 @@
                   <a:schemeClr val="tx2"/>
                 </a:solidFill>
               </a:rPr>
-              <a:t>Atendente</a:t>
+              <a:t>Colaborador</a:t>
             </a:r>
             <a:endParaRPr lang="en-US" sz="1600" dirty="0"/>
           </a:p>
@@ -11471,7 +11471,7 @@
                   <a:schemeClr val="tx1"/>
                 </a:solidFill>
               </a:rPr>
-              <a:t>recebe cliente com problema urgente e aciona o alerta</a:t>
+              <a:t>nota item trocado ou faltando e aciona o Andon</a:t>
             </a:r>
             <a:endParaRPr lang="en-US" sz="1300" dirty="0"/>
           </a:p>
@@ -11592,7 +11592,7 @@
                   <a:schemeClr val="tx2"/>
                 </a:solidFill>
               </a:rPr>
-              <a:t>Supervisor</a:t>
+              <a:t>Liderança</a:t>
             </a:r>
             <a:endParaRPr lang="en-US" sz="1600" dirty="0"/>
           </a:p>
@@ -11628,7 +11628,7 @@
                   <a:schemeClr val="tx1"/>
                 </a:solidFill>
               </a:rPr>
-              <a:t>vê o alerta na hora e vai ajudar</a:t>
+              <a:t>vem ao posto e confere o pedido</a:t>
             </a:r>
             <a:endParaRPr lang="en-US" sz="1300" dirty="0"/>
           </a:p>
@@ -11749,7 +11749,7 @@
                   <a:schemeClr val="tx2"/>
                 </a:solidFill>
               </a:rPr>
-              <a:t>Cliente</a:t>
+              <a:t>Expedição</a:t>
             </a:r>
             <a:endParaRPr lang="en-US" sz="1600" dirty="0"/>
           </a:p>
@@ -11785,7 +11785,7 @@
                   <a:schemeClr val="tx1"/>
                 </a:solidFill>
               </a:rPr>
-              <a:t>tem o problema resolvido sem esperar</a:t>
+              <a:t>o pedido sai correto para o cliente</a:t>
             </a:r>
             <a:endParaRPr lang="en-US" sz="1300" dirty="0"/>
           </a:p>
@@ -11942,7 +11942,7 @@
                   <a:schemeClr val="tx1"/>
                 </a:solidFill>
               </a:rPr>
-              <a:t>mostra quais problemas se repetem</a:t>
+              <a:t>mostra onde os erros se repetem</a:t>
             </a:r>
             <a:endParaRPr lang="en-US" sz="1300" dirty="0"/>
           </a:p>
@@ -12014,7 +12014,7 @@
                   <a:schemeClr val="tx2"/>
                 </a:solidFill>
               </a:rPr>
-              <a:t>Mesmo princípio da fábrica: </a:t>
+              <a:t>Erro barrado antes de sair: </a:t>
             </a:r>
             <a:pPr indent="0" marL="0">
               <a:buNone/>
@@ -12025,7 +12025,7 @@
                   <a:schemeClr val="tx1"/>
                 </a:solidFill>
               </a:rPr>
-              <a:t>sinalizar, chamar ajuda e registrar.</a:t>
+              <a:t>sem devolução, reenvio ou custo extra.</a:t>
             </a:r>
             <a:endParaRPr lang="en-US" sz="1800" dirty="0"/>
           </a:p>

</xml_diff>